<commit_message>
feat: Implement task management features with context API and reminders - Added TasksContext for task state management - Integrated task persistence with backend API - Created ReminderToast component for in-app notifications - Enhanced TaskBuilder for task creation and updates - Implemented reminder scheduling functionality - Updated App component to include TasksProvider
</commit_message>
<xml_diff>
--- a/docs/NeuroSync-Jury-Pitch.pptx
+++ b/docs/NeuroSync-Jury-Pitch.pptx
@@ -6236,7 +6236,17 @@
                 </a:solidFill>
                 <a:latin typeface="Segoe UI"/>
               </a:rPr>
-              <a:t>1.  Accenture — 'Getting to Equal: The Disability Inclusion Advantage' (2018). newsroom.accenture.com; accenture.com/_acnmedia/pdf-89/accenture-disability-inclusion-research-report.pdf</a:t>
+              <a:t>1.  Accenture — 'Getting to Equal: The Disability Inclusion Advantage' (2018) — </a:t>
+            </a:r>
+            <a:r>
+              <a:rPr sz="1050" b="0" i="0">
+                <a:solidFill>
+                  <a:srgbClr val="22C55E"/>
+                </a:solidFill>
+                <a:latin typeface="Segoe UI"/>
+                <a:hlinkClick r:id="rId2"/>
+              </a:rPr>
+              <a:t>https://www.accenture.com/_acnmedia/pdf-89/accenture-disability-inclusion-research-report.pdf</a:t>
             </a:r>
           </a:p>
           <a:p>
@@ -6252,7 +6262,17 @@
                 </a:solidFill>
                 <a:latin typeface="Segoe UI"/>
               </a:rPr>
-              <a:t>2.  Accenture / Disability:IN / AAPD — 'The Disability Inclusion Imperative' (2023). newsroom.accenture.com</a:t>
+              <a:t>2.  Accenture / Disability:IN / AAPD — 'The Disability Inclusion Imperative' (2023) — </a:t>
+            </a:r>
+            <a:r>
+              <a:rPr sz="1050" b="0" i="0">
+                <a:solidFill>
+                  <a:srgbClr val="22C55E"/>
+                </a:solidFill>
+                <a:latin typeface="Segoe UI"/>
+                <a:hlinkClick r:id="rId3"/>
+              </a:rPr>
+              <a:t>https://newsroom.accenture.com/news/2023/companies-that-lead-in-disability-inclusion-outperform-peers-financially-reveals-new-research-from-accenture</a:t>
             </a:r>
           </a:p>
           <a:p>
@@ -6268,7 +6288,17 @@
                 </a:solidFill>
                 <a:latin typeface="Segoe UI"/>
               </a:rPr>
-              <a:t>3.  Government of India — Rights of Persons with Disabilities Act, 2016 (recognises ASD, dyslexia, ADHD).</a:t>
+              <a:t>3.  Government of India — Rights of Persons with Disabilities Act, 2016 — </a:t>
+            </a:r>
+            <a:r>
+              <a:rPr sz="1050" b="0" i="0">
+                <a:solidFill>
+                  <a:srgbClr val="22C55E"/>
+                </a:solidFill>
+                <a:latin typeface="Segoe UI"/>
+                <a:hlinkClick r:id="rId4"/>
+              </a:rPr>
+              <a:t>https://legislative.gov.in/sites/default/files/A2016-49.pdf</a:t>
             </a:r>
           </a:p>
           <a:p>
@@ -6284,7 +6314,17 @@
                 </a:solidFill>
                 <a:latin typeface="Segoe UI"/>
               </a:rPr>
-              <a:t>4.  nasscom — 'Neurodiversity and the Future of Work in India'. community.nasscom.in</a:t>
+              <a:t>4.  nasscom — 'Neurodiversity and the Future of Work in India' — </a:t>
+            </a:r>
+            <a:r>
+              <a:rPr sz="1050" b="0" i="0">
+                <a:solidFill>
+                  <a:srgbClr val="22C55E"/>
+                </a:solidFill>
+                <a:latin typeface="Segoe UI"/>
+                <a:hlinkClick r:id="rId5"/>
+              </a:rPr>
+              <a:t>https://community.nasscom.in/communities/neurodiversity/neurodiversity-and-future-work-india</a:t>
             </a:r>
           </a:p>
           <a:p>
@@ -6300,7 +6340,17 @@
                 </a:solidFill>
                 <a:latin typeface="Segoe UI"/>
               </a:rPr>
-              <a:t>5.  HRKatha — 'The 85% invisibility: Why India's neurodiverse talent stays hidden' (2024-25).</a:t>
+              <a:t>5.  HRKatha — 'The 85% invisibility: Why India's neurodiverse talent stays hidden' (2024-25) — </a:t>
+            </a:r>
+            <a:r>
+              <a:rPr sz="1050" b="0" i="0">
+                <a:solidFill>
+                  <a:srgbClr val="22C55E"/>
+                </a:solidFill>
+                <a:latin typeface="Segoe UI"/>
+                <a:hlinkClick r:id="rId6"/>
+              </a:rPr>
+              <a:t>https://www.hrkatha.com/features/research/the-85-invisibility-why-indias-neurodiverse-talent-stays-hidden/</a:t>
             </a:r>
           </a:p>
           <a:p>
@@ -6316,7 +6366,17 @@
                 </a:solidFill>
                 <a:latin typeface="Segoe UI"/>
               </a:rPr>
-              <a:t>6.  Frontiers in Psychology (2025) — universal support for neurodivergent employees.</a:t>
+              <a:t>6.  Frontiers in Psychology (2025) — universal support for neurodivergent employees — </a:t>
+            </a:r>
+            <a:r>
+              <a:rPr sz="1050" b="0" i="0">
+                <a:solidFill>
+                  <a:srgbClr val="22C55E"/>
+                </a:solidFill>
+                <a:latin typeface="Segoe UI"/>
+                <a:hlinkClick r:id="rId7"/>
+              </a:rPr>
+              <a:t>https://www.frontiersin.org/journals/psychology/articles/10.3389/fpsyg.2025.1547877/full</a:t>
             </a:r>
           </a:p>
           <a:p>
@@ -6332,7 +6392,17 @@
                 </a:solidFill>
                 <a:latin typeface="Segoe UI"/>
               </a:rPr>
-              <a:t>7.  Branicki et al. — Human Resource Management, Wiley (2024): flexible/home working &amp; neurodivergent outcomes.</a:t>
+              <a:t>7.  Branicki et al. — Human Resource Management, Wiley (2024) — </a:t>
+            </a:r>
+            <a:r>
+              <a:rPr sz="1050" b="0" i="0">
+                <a:solidFill>
+                  <a:srgbClr val="22C55E"/>
+                </a:solidFill>
+                <a:latin typeface="Segoe UI"/>
+                <a:hlinkClick r:id="rId8"/>
+              </a:rPr>
+              <a:t>https://onlinelibrary.wiley.com/doi/10.1002/hrm.22243</a:t>
             </a:r>
           </a:p>
           <a:p>
@@ -6348,7 +6418,17 @@
                 </a:solidFill>
                 <a:latin typeface="Segoe UI"/>
               </a:rPr>
-              <a:t>8.  mydisabilityjobs.com — 'Neurodiversity in the Workplace | Statistics' (2025).</a:t>
+              <a:t>8.  mydisabilityjobs.com — 'Neurodiversity in the Workplace | Statistics' (2025) — </a:t>
+            </a:r>
+            <a:r>
+              <a:rPr sz="1050" b="0" i="0">
+                <a:solidFill>
+                  <a:srgbClr val="22C55E"/>
+                </a:solidFill>
+                <a:latin typeface="Segoe UI"/>
+                <a:hlinkClick r:id="rId9"/>
+              </a:rPr>
+              <a:t>https://mydisabilityjobs.com/statistics/neurodiversity-in-the-workplace/</a:t>
             </a:r>
           </a:p>
           <a:p>
@@ -6364,7 +6444,17 @@
                 </a:solidFill>
                 <a:latin typeface="Segoe UI"/>
               </a:rPr>
-              <a:t>9.  Disability:IN — evidence-based neuroinclusion framework.</a:t>
+              <a:t>9.  Disability:IN — evidence-based neuroinclusion framework — </a:t>
+            </a:r>
+            <a:r>
+              <a:rPr sz="1050" b="0" i="0">
+                <a:solidFill>
+                  <a:srgbClr val="22C55E"/>
+                </a:solidFill>
+                <a:latin typeface="Segoe UI"/>
+                <a:hlinkClick r:id="rId10"/>
+              </a:rPr>
+              <a:t>https://disabilityin.org/articles-and-updates/disability-in-unveils-innovative-evidence-based-framework-to-advance-neuroinclusion-in-the-workforce</a:t>
             </a:r>
           </a:p>
         </p:txBody>
@@ -7423,6 +7513,16 @@
               </a:rPr>
               <a:t>15–20%</a:t>
             </a:r>
+            <a:r>
+              <a:rPr sz="1300" b="1" i="0" baseline="30000">
+                <a:solidFill>
+                  <a:srgbClr val="22C55E"/>
+                </a:solidFill>
+                <a:latin typeface="Segoe UI"/>
+                <a:hlinkClick r:id="rId2"/>
+              </a:rPr>
+              <a:t> 8</a:t>
+            </a:r>
           </a:p>
           <a:p>
             <a:pPr algn="l">
@@ -7522,6 +7622,16 @@
               </a:rPr>
               <a:t>~1 in 2</a:t>
             </a:r>
+            <a:r>
+              <a:rPr sz="1300" b="1" i="0" baseline="30000">
+                <a:solidFill>
+                  <a:srgbClr val="22C55E"/>
+                </a:solidFill>
+                <a:latin typeface="Segoe UI"/>
+                <a:hlinkClick r:id="rId2"/>
+              </a:rPr>
+              <a:t> 8</a:t>
+            </a:r>
           </a:p>
           <a:p>
             <a:pPr algn="l">
@@ -7620,6 +7730,16 @@
                 <a:latin typeface="Segoe UI"/>
               </a:rPr>
               <a:t>+28% / 2x / +30%</a:t>
+            </a:r>
+            <a:r>
+              <a:rPr sz="1300" b="1" i="0" baseline="30000">
+                <a:solidFill>
+                  <a:srgbClr val="22C55E"/>
+                </a:solidFill>
+                <a:latin typeface="Segoe UI"/>
+                <a:hlinkClick r:id="rId3"/>
+              </a:rPr>
+              <a:t> 1</a:t>
             </a:r>
           </a:p>
           <a:p>

</xml_diff>

<commit_message>
feat: enhance Outlook integration and user experience
- Implemented "reduce motion" CSS for accessibility preferences.
- Refactored main rendering logic to handle Microsoft sign-in redirects more efficiently.
- Improved Outlook service with better token management and error handling.
- Added a blank HTML file for MSAL sign-in redirection.
- Created DashboardHome component for a user-friendly task overview.
- Developed FocusSession component for focused work sessions with a countdown timer.
- Introduced OnboardingModal for user personalization settings during signup.
- Added ProfileCompareModal to demonstrate adaptive output based on user profiles.
- Implemented text extraction utility for handling PDF and DOCX uploads.
</commit_message>
<xml_diff>
--- a/docs/NeuroSync-Jury-Pitch.pptx
+++ b/docs/NeuroSync-Jury-Pitch.pptx
@@ -5472,7 +5472,7 @@
                 </a:solidFill>
                 <a:latin typeface="Segoe UI"/>
               </a:rPr>
-              <a:t>•  AI task breakdown</a:t>
+              <a:t>•  AI task breakdown + summarizer</a:t>
             </a:r>
           </a:p>
           <a:p>
@@ -5488,7 +5488,7 @@
                 </a:solidFill>
                 <a:latin typeface="Segoe UI"/>
               </a:rPr>
-              <a:t>•  Plain-language summarizer</a:t>
+              <a:t>•  Per-user personalization</a:t>
             </a:r>
           </a:p>
           <a:p>
@@ -5504,6 +5504,22 @@
                 </a:solidFill>
                 <a:latin typeface="Segoe UI"/>
               </a:rPr>
+              <a:t>•  Projects + due dates</a:t>
+            </a:r>
+          </a:p>
+          <a:p>
+            <a:pPr algn="l">
+              <a:spcAft>
+                <a:spcPts val="700"/>
+              </a:spcAft>
+            </a:pPr>
+            <a:r>
+              <a:rPr sz="1300" b="0" i="0">
+                <a:solidFill>
+                  <a:srgbClr val="111827"/>
+                </a:solidFill>
+                <a:latin typeface="Segoe UI"/>
+              </a:rPr>
               <a:t>•  Outlook email -&gt; task</a:t>
             </a:r>
           </a:p>
@@ -5520,7 +5536,7 @@
                 </a:solidFill>
                 <a:latin typeface="Segoe UI"/>
               </a:rPr>
-              <a:t>•  Focus mode + overwhelm reset</a:t>
+              <a:t>•  Azure OpenAI in-tenant</a:t>
             </a:r>
           </a:p>
         </p:txBody>
@@ -5637,7 +5653,7 @@
                 </a:solidFill>
                 <a:latin typeface="Segoe UI"/>
               </a:rPr>
-              <a:t>•  Azure OpenAI in-tenant</a:t>
+              <a:t>•  Teams &amp; Jira connectors</a:t>
             </a:r>
           </a:p>
           <a:p>
@@ -5653,7 +5669,7 @@
                 </a:solidFill>
                 <a:latin typeface="Segoe UI"/>
               </a:rPr>
-              <a:t>•  Teams &amp; Jira connectors</a:t>
+              <a:t>•  More language / low-vision profiles</a:t>
             </a:r>
           </a:p>
         </p:txBody>
@@ -8189,7 +8205,7 @@
                 </a:solidFill>
                 <a:latin typeface="Segoe UI"/>
               </a:rPr>
-              <a:t>"Same message, rendered for your brain." The same email becomes time-boxed steps (ADHD) or short, plain, dyslexia-friendly text — Copilot gives everyone the identical summary.</a:t>
+              <a:t>"Same message, rendered for your brain." A one-time profile you set makes the same email become time-boxed steps (ADHD) or short, plain, dyslexia-friendly text. Copilot gives everyone the identical answer — we adapt to the person.</a:t>
             </a:r>
           </a:p>
         </p:txBody>
@@ -8630,7 +8646,7 @@
                 </a:solidFill>
                 <a:latin typeface="Segoe UI"/>
               </a:rPr>
-              <a:t>•   Paste Aanya's messy email — or pull it straight from Outlook (Microsoft Graph).</a:t>
+              <a:t>•   Open the profile — NeuroSync already knows Aanya prefers short text and small steps.</a:t>
             </a:r>
           </a:p>
           <a:p>
@@ -8646,7 +8662,7 @@
                 </a:solidFill>
                 <a:latin typeface="Segoe UI"/>
               </a:rPr>
-              <a:t>•   NeuroSync returns a plain summary, the real action items, and the hidden Thursday deadline.</a:t>
+              <a:t>•   Paste her messy email (or pull it from Outlook) → summary, real action items, the hidden Thursday deadline.</a:t>
             </a:r>
           </a:p>
           <a:p>
@@ -8662,7 +8678,7 @@
                 </a:solidFill>
                 <a:latin typeface="Segoe UI"/>
               </a:rPr>
-              <a:t>•   Toggle Dyslexia mode — the same content, re-rendered for a dyslexic reader.</a:t>
+              <a:t>•   The dyslexia-friendly rewrite is short + bulleted — rendered to HER profile, not a generic answer.</a:t>
             </a:r>
           </a:p>
           <a:p>
@@ -8678,7 +8694,7 @@
                 </a:solidFill>
                 <a:latin typeface="Segoe UI"/>
               </a:rPr>
-              <a:t>•   Send it to the Planner — AI breaks it into ordered micro-steps with time estimates.</a:t>
+              <a:t>•   Convert to tasks → one task with AI-described micro-steps and time estimates.</a:t>
             </a:r>
           </a:p>
           <a:p>
@@ -8777,7 +8793,7 @@
                 </a:solidFill>
                 <a:latin typeface="Segoe UI"/>
               </a:rPr>
-              <a:t>Running live on real AI (Google Gemini today; Azure OpenAI in production).</a:t>
+              <a:t>Running live on Azure OpenAI (in your tenant) — and personalised to each user.</a:t>
             </a:r>
           </a:p>
         </p:txBody>
@@ -9961,7 +9977,7 @@
                 </a:solidFill>
                 <a:latin typeface="Segoe UI"/>
               </a:rPr>
-              <a:t>•   Working MVP: React frontend + ASP.NET Core API + SQL on Azure, with real AI (Google Gemini).</a:t>
+              <a:t>•   Working MVP on Azure: React + ASP.NET Core + SQL + Azure OpenAI — Tasks, Projects, the Summarizer, and per-user personalization are all live.</a:t>
             </a:r>
           </a:p>
           <a:p>

</xml_diff>